<commit_message>
Add contribution to slides
</commit_message>
<xml_diff>
--- a/Cybersecurity.pptx
+++ b/Cybersecurity.pptx
@@ -143,7 +143,7 @@
 <file path=ppt/revisionInfo.xml><?xml version="1.0" encoding="utf-8"?>
 <p1510:revInfo xmlns:a="http://schemas.openxmlformats.org/drawingml/2006/main" xmlns:r="http://schemas.openxmlformats.org/officeDocument/2006/relationships" xmlns:p1510="http://schemas.microsoft.com/office/powerpoint/2015/10/main">
   <p1510:revLst>
-    <p1510:client id="{A8CAAC88-61F1-4218-9F39-C9973C2406C4}" v="2" dt="2026-10-17T22:06:24.270"/>
+    <p1510:client id="{A8CAAC88-61F1-4218-9F39-C9973C2406C4}" v="11" dt="2026-10-18T19:53:23.681"/>
   </p1510:revLst>
 </p1510:revInfo>
 </file>
@@ -152,8 +152,8 @@
 <pc:chgInfo xmlns:a="http://schemas.openxmlformats.org/drawingml/2006/main" xmlns:r="http://schemas.openxmlformats.org/officeDocument/2006/relationships" xmlns:ac="http://schemas.microsoft.com/office/drawing/2013/main/command" xmlns:pc="http://schemas.microsoft.com/office/powerpoint/2013/main/command">
   <pc:docChgLst>
     <pc:chgData name="Hayden Hermolin" userId="431248b8-cdb2-41a6-b1f6-9c9212bc7112" providerId="ADAL" clId="{3F71D0EB-0A57-4AB9-8952-1858B8B267AA}"/>
-    <pc:docChg chg="modSld">
-      <pc:chgData name="Hayden Hermolin" userId="431248b8-cdb2-41a6-b1f6-9c9212bc7112" providerId="ADAL" clId="{3F71D0EB-0A57-4AB9-8952-1858B8B267AA}" dt="2026-10-17T22:06:24.270" v="1"/>
+    <pc:docChg chg="undo custSel modSld">
+      <pc:chgData name="Hayden Hermolin" userId="431248b8-cdb2-41a6-b1f6-9c9212bc7112" providerId="ADAL" clId="{3F71D0EB-0A57-4AB9-8952-1858B8B267AA}" dt="2026-10-18T19:56:56.964" v="572" actId="20577"/>
       <pc:docMkLst>
         <pc:docMk/>
       </pc:docMkLst>
@@ -169,6 +169,52 @@
             <pc:docMk/>
             <pc:sldMk cId="2329614230" sldId="260"/>
             <ac:spMk id="4" creationId="{D8319D33-1EDC-2FD6-1393-613ECEB01295}"/>
+          </ac:spMkLst>
+        </pc:spChg>
+      </pc:sldChg>
+      <pc:sldChg chg="modSp mod">
+        <pc:chgData name="Hayden Hermolin" userId="431248b8-cdb2-41a6-b1f6-9c9212bc7112" providerId="ADAL" clId="{3F71D0EB-0A57-4AB9-8952-1858B8B267AA}" dt="2026-10-18T19:56:56.964" v="572" actId="20577"/>
+        <pc:sldMkLst>
+          <pc:docMk/>
+          <pc:sldMk cId="1888392706" sldId="261"/>
+        </pc:sldMkLst>
+        <pc:spChg chg="mod">
+          <ac:chgData name="Hayden Hermolin" userId="431248b8-cdb2-41a6-b1f6-9c9212bc7112" providerId="ADAL" clId="{3F71D0EB-0A57-4AB9-8952-1858B8B267AA}" dt="2026-10-18T19:56:00.451" v="560" actId="20577"/>
+          <ac:spMkLst>
+            <pc:docMk/>
+            <pc:sldMk cId="1888392706" sldId="261"/>
+            <ac:spMk id="2" creationId="{80132F40-8E50-96F5-D088-FCB55F9901FA}"/>
+          </ac:spMkLst>
+        </pc:spChg>
+        <pc:spChg chg="mod">
+          <ac:chgData name="Hayden Hermolin" userId="431248b8-cdb2-41a6-b1f6-9c9212bc7112" providerId="ADAL" clId="{3F71D0EB-0A57-4AB9-8952-1858B8B267AA}" dt="2026-10-18T19:56:56.964" v="572" actId="20577"/>
+          <ac:spMkLst>
+            <pc:docMk/>
+            <pc:sldMk cId="1888392706" sldId="261"/>
+            <ac:spMk id="3" creationId="{E74C8192-285E-AC84-3843-942AA147A91E}"/>
+          </ac:spMkLst>
+        </pc:spChg>
+      </pc:sldChg>
+      <pc:sldChg chg="modSp mod">
+        <pc:chgData name="Hayden Hermolin" userId="431248b8-cdb2-41a6-b1f6-9c9212bc7112" providerId="ADAL" clId="{3F71D0EB-0A57-4AB9-8952-1858B8B267AA}" dt="2026-10-18T19:54:13.881" v="559" actId="20577"/>
+        <pc:sldMkLst>
+          <pc:docMk/>
+          <pc:sldMk cId="2055364835" sldId="262"/>
+        </pc:sldMkLst>
+        <pc:spChg chg="mod">
+          <ac:chgData name="Hayden Hermolin" userId="431248b8-cdb2-41a6-b1f6-9c9212bc7112" providerId="ADAL" clId="{3F71D0EB-0A57-4AB9-8952-1858B8B267AA}" dt="2026-10-18T19:47:57.434" v="232"/>
+          <ac:spMkLst>
+            <pc:docMk/>
+            <pc:sldMk cId="2055364835" sldId="262"/>
+            <ac:spMk id="2" creationId="{C013E781-5DB1-3165-0165-E31F7D390581}"/>
+          </ac:spMkLst>
+        </pc:spChg>
+        <pc:spChg chg="mod">
+          <ac:chgData name="Hayden Hermolin" userId="431248b8-cdb2-41a6-b1f6-9c9212bc7112" providerId="ADAL" clId="{3F71D0EB-0A57-4AB9-8952-1858B8B267AA}" dt="2026-10-18T19:54:13.881" v="559" actId="20577"/>
+          <ac:spMkLst>
+            <pc:docMk/>
+            <pc:sldMk cId="2055364835" sldId="262"/>
+            <ac:spMk id="3" creationId="{AAB10167-F30E-D14A-00D7-17937BE1F09F}"/>
           </ac:spMkLst>
         </pc:spChg>
       </pc:sldChg>
@@ -271,7 +317,7 @@
           <a:p>
             <a:fld id="{F223FF85-4E34-4546-B772-76DFA4A6051B}" type="datetimeFigureOut">
               <a:rPr lang="en-US" smtClean="0"/>
-              <a:t>10/17/2026</a:t>
+              <a:t>10/18/2026</a:t>
             </a:fld>
             <a:endParaRPr lang="en-US"/>
           </a:p>
@@ -448,7 +494,7 @@
           <a:p>
             <a:fld id="{1B5CC398-6116-4BD2-9FAD-9822FDA158BE}" type="datetimeFigureOut">
               <a:rPr lang="en-US" smtClean="0"/>
-              <a:t>10/17/2026</a:t>
+              <a:t>10/18/2026</a:t>
             </a:fld>
             <a:endParaRPr lang="en-US"/>
           </a:p>
@@ -13921,38 +13967,201 @@
         </p:nvSpPr>
         <p:spPr/>
         <p:txBody>
-          <a:bodyPr/>
+          <a:bodyPr>
+            <a:normAutofit fontScale="90000"/>
+          </a:bodyPr>
           <a:lstStyle/>
           <a:p>
             <a:r>
+              <a:rPr lang="en-CA" b="1" dirty="0"/>
+              <a:t>What are Data breaches?</a:t>
+            </a:r>
+            <a:br>
+              <a:rPr lang="en-CA" b="1" dirty="0"/>
+            </a:br>
+            <a:br>
+              <a:rPr lang="en-CA" b="1" dirty="0"/>
+            </a:br>
+            <a:r>
+              <a:rPr lang="en-CA" b="1" dirty="0"/>
+              <a:t>how do they happen?</a:t>
+            </a:r>
+          </a:p>
+        </p:txBody>
+      </p:sp>
+      <p:sp>
+        <p:nvSpPr>
+          <p:cNvPr id="3" name="Content Placeholder 2">
+            <a:extLst>
+              <a:ext uri="{FF2B5EF4-FFF2-40B4-BE49-F238E27FC236}">
+                <a16:creationId xmlns:a16="http://schemas.microsoft.com/office/drawing/2014/main" id="{E74C8192-285E-AC84-3843-942AA147A91E}"/>
+              </a:ext>
+            </a:extLst>
+          </p:cNvPr>
+          <p:cNvSpPr>
+            <a:spLocks noGrp="1"/>
+          </p:cNvSpPr>
+          <p:nvPr>
+            <p:ph sz="quarter" idx="13"/>
+          </p:nvPr>
+        </p:nvSpPr>
+        <p:spPr>
+          <a:xfrm>
+            <a:off x="6324600" y="1385287"/>
+            <a:ext cx="5181600" cy="4573655"/>
+          </a:xfrm>
+        </p:spPr>
+        <p:txBody>
+          <a:bodyPr>
+            <a:normAutofit fontScale="92500" lnSpcReduction="20000"/>
+          </a:bodyPr>
+          <a:lstStyle/>
+          <a:p>
+            <a:pPr marL="514350" indent="-285750">
+              <a:buFont typeface="Arial" panose="020B0604020202020204" pitchFamily="34" charset="0"/>
+              <a:buChar char="•"/>
+            </a:pPr>
+            <a:r>
               <a:rPr lang="en-CA" dirty="0"/>
-              <a:t>1</a:t>
-            </a:r>
-          </a:p>
-        </p:txBody>
-      </p:sp>
-      <p:sp>
-        <p:nvSpPr>
-          <p:cNvPr id="3" name="Content Placeholder 2">
-            <a:extLst>
-              <a:ext uri="{FF2B5EF4-FFF2-40B4-BE49-F238E27FC236}">
-                <a16:creationId xmlns:a16="http://schemas.microsoft.com/office/drawing/2014/main" id="{E74C8192-285E-AC84-3843-942AA147A91E}"/>
-              </a:ext>
-            </a:extLst>
-          </p:cNvPr>
-          <p:cNvSpPr>
-            <a:spLocks noGrp="1"/>
-          </p:cNvSpPr>
-          <p:nvPr>
-            <p:ph sz="quarter" idx="13"/>
-          </p:nvPr>
-        </p:nvSpPr>
-        <p:spPr/>
-        <p:txBody>
-          <a:bodyPr/>
-          <a:lstStyle/>
-          <a:p>
-            <a:endParaRPr lang="en-CA"/>
+              <a:t>Unintentional release of information</a:t>
+            </a:r>
+          </a:p>
+          <a:p>
+            <a:pPr marL="514350" indent="-285750">
+              <a:buFont typeface="Arial" panose="020B0604020202020204" pitchFamily="34" charset="0"/>
+              <a:buChar char="•"/>
+            </a:pPr>
+            <a:r>
+              <a:rPr lang="en-CA" dirty="0"/>
+              <a:t>Deliberate</a:t>
+            </a:r>
+          </a:p>
+          <a:p>
+            <a:pPr marL="742950" lvl="1" indent="-285750">
+              <a:buFont typeface="Arial" panose="020B0604020202020204" pitchFamily="34" charset="0"/>
+              <a:buChar char="•"/>
+            </a:pPr>
+            <a:r>
+              <a:rPr lang="en-CA" dirty="0"/>
+              <a:t>Phishing</a:t>
+            </a:r>
+          </a:p>
+          <a:p>
+            <a:pPr marL="742950" lvl="1" indent="-285750">
+              <a:buFont typeface="Arial" panose="020B0604020202020204" pitchFamily="34" charset="0"/>
+              <a:buChar char="•"/>
+            </a:pPr>
+            <a:r>
+              <a:rPr lang="en-CA" dirty="0"/>
+              <a:t>Ransomware</a:t>
+            </a:r>
+          </a:p>
+          <a:p>
+            <a:pPr marL="742950" lvl="1" indent="-285750">
+              <a:buFont typeface="Arial" panose="020B0604020202020204" pitchFamily="34" charset="0"/>
+              <a:buChar char="•"/>
+            </a:pPr>
+            <a:r>
+              <a:rPr lang="en-CA" dirty="0"/>
+              <a:t>Theft</a:t>
+            </a:r>
+          </a:p>
+          <a:p>
+            <a:pPr marL="742950" lvl="1" indent="-285750">
+              <a:buFont typeface="Arial" panose="020B0604020202020204" pitchFamily="34" charset="0"/>
+              <a:buChar char="•"/>
+            </a:pPr>
+            <a:r>
+              <a:rPr lang="en-CA" dirty="0"/>
+              <a:t>Exploit</a:t>
+            </a:r>
+          </a:p>
+          <a:p>
+            <a:pPr marL="742950" lvl="1" indent="-285750">
+              <a:buFont typeface="Arial" panose="020B0604020202020204" pitchFamily="34" charset="0"/>
+              <a:buChar char="•"/>
+            </a:pPr>
+            <a:r>
+              <a:rPr lang="en-CA" dirty="0"/>
+              <a:t>Leaks</a:t>
+            </a:r>
+          </a:p>
+          <a:p>
+            <a:pPr marL="742950" lvl="1" indent="-285750">
+              <a:buFont typeface="Arial" panose="020B0604020202020204" pitchFamily="34" charset="0"/>
+              <a:buChar char="•"/>
+            </a:pPr>
+            <a:r>
+              <a:rPr lang="en-CA" dirty="0"/>
+              <a:t>Bribery</a:t>
+            </a:r>
+          </a:p>
+          <a:p>
+            <a:pPr marL="742950" lvl="1" indent="-285750">
+              <a:buFont typeface="Arial" panose="020B0604020202020204" pitchFamily="34" charset="0"/>
+              <a:buChar char="•"/>
+            </a:pPr>
+            <a:r>
+              <a:rPr lang="en-CA" dirty="0"/>
+              <a:t>Espionage</a:t>
+            </a:r>
+          </a:p>
+          <a:p>
+            <a:pPr marL="514350" indent="-285750">
+              <a:buFont typeface="Arial" panose="020B0604020202020204" pitchFamily="34" charset="0"/>
+              <a:buChar char="•"/>
+            </a:pPr>
+            <a:r>
+              <a:rPr lang="en-CA" dirty="0"/>
+              <a:t>Accidental</a:t>
+            </a:r>
+          </a:p>
+          <a:p>
+            <a:pPr marL="742950" lvl="1" indent="-285750">
+              <a:buFont typeface="Arial" panose="020B0604020202020204" pitchFamily="34" charset="0"/>
+              <a:buChar char="•"/>
+            </a:pPr>
+            <a:r>
+              <a:rPr lang="en-CA" dirty="0"/>
+              <a:t>Lost</a:t>
+            </a:r>
+          </a:p>
+          <a:p>
+            <a:pPr marL="742950" lvl="1" indent="-285750">
+              <a:buFont typeface="Arial" panose="020B0604020202020204" pitchFamily="34" charset="0"/>
+              <a:buChar char="•"/>
+            </a:pPr>
+            <a:r>
+              <a:rPr lang="en-CA" dirty="0"/>
+              <a:t>Misplaced</a:t>
+            </a:r>
+          </a:p>
+          <a:p>
+            <a:pPr marL="514350" indent="-285750">
+              <a:buFont typeface="Arial" panose="020B0604020202020204" pitchFamily="34" charset="0"/>
+              <a:buChar char="•"/>
+            </a:pPr>
+            <a:r>
+              <a:rPr lang="en-CA" dirty="0"/>
+              <a:t>Proxy</a:t>
+            </a:r>
+          </a:p>
+          <a:p>
+            <a:pPr marL="742950" lvl="1" indent="-285750">
+              <a:buFont typeface="Arial" panose="020B0604020202020204" pitchFamily="34" charset="0"/>
+              <a:buChar char="•"/>
+            </a:pPr>
+            <a:r>
+              <a:rPr lang="en-CA" dirty="0"/>
+              <a:t>Third party service breach</a:t>
+            </a:r>
+          </a:p>
+          <a:p>
+            <a:pPr marL="742950" lvl="1" indent="-285750">
+              <a:buFont typeface="Arial" panose="020B0604020202020204" pitchFamily="34" charset="0"/>
+              <a:buChar char="•"/>
+            </a:pPr>
+            <a:endParaRPr lang="en-CA" dirty="0"/>
           </a:p>
         </p:txBody>
       </p:sp>
@@ -14008,34 +14217,178 @@
           <a:lstStyle/>
           <a:p>
             <a:r>
+              <a:rPr lang="en-CA" b="1" dirty="0"/>
+              <a:t>History of data breaches</a:t>
+            </a:r>
+          </a:p>
+        </p:txBody>
+      </p:sp>
+      <p:sp>
+        <p:nvSpPr>
+          <p:cNvPr id="3" name="Content Placeholder 2">
+            <a:extLst>
+              <a:ext uri="{FF2B5EF4-FFF2-40B4-BE49-F238E27FC236}">
+                <a16:creationId xmlns:a16="http://schemas.microsoft.com/office/drawing/2014/main" id="{AAB10167-F30E-D14A-00D7-17937BE1F09F}"/>
+              </a:ext>
+            </a:extLst>
+          </p:cNvPr>
+          <p:cNvSpPr>
+            <a:spLocks noGrp="1"/>
+          </p:cNvSpPr>
+          <p:nvPr>
+            <p:ph sz="quarter" idx="13"/>
+          </p:nvPr>
+        </p:nvSpPr>
+        <p:spPr>
+          <a:xfrm>
+            <a:off x="704084" y="1600199"/>
+            <a:ext cx="5735507" cy="5119719"/>
+          </a:xfrm>
+        </p:spPr>
+        <p:txBody>
+          <a:bodyPr>
+            <a:normAutofit lnSpcReduction="10000"/>
+          </a:bodyPr>
+          <a:lstStyle/>
+          <a:p>
+            <a:pPr marL="514350" indent="-285750">
+              <a:buFont typeface="Arial" panose="020B0604020202020204" pitchFamily="34" charset="0"/>
+              <a:buChar char="•"/>
+            </a:pPr>
+            <a:r>
               <a:rPr lang="en-CA" dirty="0"/>
-              <a:t>2</a:t>
-            </a:r>
-          </a:p>
-        </p:txBody>
-      </p:sp>
-      <p:sp>
-        <p:nvSpPr>
-          <p:cNvPr id="3" name="Content Placeholder 2">
-            <a:extLst>
-              <a:ext uri="{FF2B5EF4-FFF2-40B4-BE49-F238E27FC236}">
-                <a16:creationId xmlns:a16="http://schemas.microsoft.com/office/drawing/2014/main" id="{AAB10167-F30E-D14A-00D7-17937BE1F09F}"/>
-              </a:ext>
-            </a:extLst>
-          </p:cNvPr>
-          <p:cNvSpPr>
-            <a:spLocks noGrp="1"/>
-          </p:cNvSpPr>
-          <p:nvPr>
-            <p:ph sz="quarter" idx="13"/>
-          </p:nvPr>
-        </p:nvSpPr>
-        <p:spPr/>
-        <p:txBody>
-          <a:bodyPr/>
-          <a:lstStyle/>
-          <a:p>
-            <a:endParaRPr lang="en-CA" dirty="0"/>
+              <a:t>September 2026</a:t>
+            </a:r>
+          </a:p>
+          <a:p>
+            <a:pPr marL="742950" lvl="1" indent="-285750">
+              <a:buFont typeface="Arial" panose="020B0604020202020204" pitchFamily="34" charset="0"/>
+              <a:buChar char="•"/>
+            </a:pPr>
+            <a:r>
+              <a:rPr lang="en-CA" dirty="0"/>
+              <a:t>Seven public breaches</a:t>
+            </a:r>
+          </a:p>
+          <a:p>
+            <a:pPr marL="742950" lvl="1" indent="-285750">
+              <a:buFont typeface="Arial" panose="020B0604020202020204" pitchFamily="34" charset="0"/>
+              <a:buChar char="•"/>
+            </a:pPr>
+            <a:r>
+              <a:rPr lang="en-CA" dirty="0"/>
+              <a:t>42+ million records</a:t>
+            </a:r>
+          </a:p>
+          <a:p>
+            <a:pPr marL="514350" indent="-285750">
+              <a:buFont typeface="Arial" panose="020B0604020202020204" pitchFamily="34" charset="0"/>
+              <a:buChar char="•"/>
+            </a:pPr>
+            <a:r>
+              <a:rPr lang="en-CA" dirty="0"/>
+              <a:t>Yahoo (2013)</a:t>
+            </a:r>
+          </a:p>
+          <a:p>
+            <a:pPr marL="742950" lvl="1" indent="-285750">
+              <a:buFont typeface="Arial" panose="020B0604020202020204" pitchFamily="34" charset="0"/>
+              <a:buChar char="•"/>
+            </a:pPr>
+            <a:r>
+              <a:rPr lang="en-CA" dirty="0"/>
+              <a:t>3+ billion accounts</a:t>
+            </a:r>
+          </a:p>
+          <a:p>
+            <a:pPr marL="742950" lvl="1" indent="-285750">
+              <a:buFont typeface="Arial" panose="020B0604020202020204" pitchFamily="34" charset="0"/>
+              <a:buChar char="•"/>
+            </a:pPr>
+            <a:r>
+              <a:rPr lang="en-CA" dirty="0"/>
+              <a:t>Acknowledged in 2016</a:t>
+            </a:r>
+          </a:p>
+          <a:p>
+            <a:pPr marL="742950" lvl="1" indent="-285750">
+              <a:buFont typeface="Arial" panose="020B0604020202020204" pitchFamily="34" charset="0"/>
+              <a:buChar char="•"/>
+            </a:pPr>
+            <a:r>
+              <a:rPr lang="en-CA" dirty="0"/>
+              <a:t>Names, emails, phone numbers, DOBs, etc.</a:t>
+            </a:r>
+          </a:p>
+          <a:p>
+            <a:pPr marL="742950" lvl="1" indent="-285750">
+              <a:buFont typeface="Arial" panose="020B0604020202020204" pitchFamily="34" charset="0"/>
+              <a:buChar char="•"/>
+            </a:pPr>
+            <a:r>
+              <a:rPr lang="en-CA" dirty="0"/>
+              <a:t>-$300 million to sale price</a:t>
+            </a:r>
+          </a:p>
+          <a:p>
+            <a:pPr marL="514350" indent="-285750">
+              <a:buFont typeface="Arial" panose="020B0604020202020204" pitchFamily="34" charset="0"/>
+              <a:buChar char="•"/>
+            </a:pPr>
+            <a:r>
+              <a:rPr lang="en-CA" dirty="0"/>
+              <a:t>First American Financial (2019)</a:t>
+            </a:r>
+          </a:p>
+          <a:p>
+            <a:pPr marL="742950" lvl="1" indent="-285750">
+              <a:buFont typeface="Arial" panose="020B0604020202020204" pitchFamily="34" charset="0"/>
+              <a:buChar char="•"/>
+            </a:pPr>
+            <a:r>
+              <a:rPr lang="en-CA" dirty="0"/>
+              <a:t>885+ million records</a:t>
+            </a:r>
+          </a:p>
+          <a:p>
+            <a:pPr marL="514350" indent="-285750">
+              <a:buFont typeface="Arial" panose="020B0604020202020204" pitchFamily="34" charset="0"/>
+              <a:buChar char="•"/>
+            </a:pPr>
+            <a:r>
+              <a:rPr lang="en-CA" dirty="0"/>
+              <a:t>Marriott International (2018)</a:t>
+            </a:r>
+          </a:p>
+          <a:p>
+            <a:pPr marL="742950" lvl="1" indent="-285750">
+              <a:buFont typeface="Arial" panose="020B0604020202020204" pitchFamily="34" charset="0"/>
+              <a:buChar char="•"/>
+            </a:pPr>
+            <a:r>
+              <a:rPr lang="en-CA" dirty="0"/>
+              <a:t>383+ million records</a:t>
+            </a:r>
+          </a:p>
+          <a:p>
+            <a:pPr marL="514350" indent="-285750">
+              <a:buFont typeface="Arial" panose="020B0604020202020204" pitchFamily="34" charset="0"/>
+              <a:buChar char="•"/>
+            </a:pPr>
+            <a:r>
+              <a:rPr lang="en-CA" dirty="0"/>
+              <a:t>National Public Data (2024)</a:t>
+            </a:r>
+          </a:p>
+          <a:p>
+            <a:pPr marL="742950" lvl="1" indent="-285750">
+              <a:buFont typeface="Arial" panose="020B0604020202020204" pitchFamily="34" charset="0"/>
+              <a:buChar char="•"/>
+            </a:pPr>
+            <a:r>
+              <a:rPr lang="en-CA" dirty="0"/>
+              <a:t>2.9+ billion records</a:t>
+            </a:r>
           </a:p>
         </p:txBody>
       </p:sp>
@@ -15133,35 +15486,6 @@
 </file>
 
 <file path=customXml/item1.xml><?xml version="1.0" encoding="utf-8"?>
-<?mso-contentType ?>
-<FormTemplates xmlns="http://schemas.microsoft.com/sharepoint/v3/contenttype/forms">
-  <Display>DocumentLibraryForm</Display>
-  <Edit>DocumentLibraryForm</Edit>
-  <New>DocumentLibraryForm</New>
-</FormTemplates>
-</file>
-
-<file path=customXml/item2.xml><?xml version="1.0" encoding="utf-8"?>
-<p:properties xmlns:p="http://schemas.microsoft.com/office/2006/metadata/properties" xmlns:xsi="http://www.w3.org/2001/XMLSchema-instance" xmlns:pc="http://schemas.microsoft.com/office/infopath/2007/PartnerControls">
-  <documentManagement>
-    <_ip_UnifiedCompliancePolicyUIAction xmlns="http://schemas.microsoft.com/sharepoint/v3" xsi:nil="true"/>
-    <Image xmlns="71af3243-3dd4-4a8d-8c0d-dd76da1f02a5">
-      <Url xsi:nil="true"/>
-      <Description xsi:nil="true"/>
-    </Image>
-    <Status xmlns="71af3243-3dd4-4a8d-8c0d-dd76da1f02a5">Not started</Status>
-    <Background xmlns="71af3243-3dd4-4a8d-8c0d-dd76da1f02a5">false</Background>
-    <_ip_UnifiedCompliancePolicyProperties xmlns="http://schemas.microsoft.com/sharepoint/v3" xsi:nil="true"/>
-    <ImageTagsTaxHTField xmlns="71af3243-3dd4-4a8d-8c0d-dd76da1f02a5">
-      <Terms xmlns="http://schemas.microsoft.com/office/infopath/2007/PartnerControls"/>
-    </ImageTagsTaxHTField>
-    <TaxCatchAll xmlns="230e9df3-be65-4c73-a93b-d1236ebd677e" xsi:nil="true"/>
-    <MediaServiceKeyPoints xmlns="71af3243-3dd4-4a8d-8c0d-dd76da1f02a5" xsi:nil="true"/>
-  </documentManagement>
-</p:properties>
-</file>
-
-<file path=customXml/item3.xml><?xml version="1.0" encoding="utf-8"?>
 <ct:contentTypeSchema xmlns:ct="http://schemas.microsoft.com/office/2006/metadata/contentType" xmlns:ma="http://schemas.microsoft.com/office/2006/metadata/properties/metaAttributes" ct:_="" ma:_="" ma:contentTypeName="Document" ma:contentTypeID="0x01010079F111ED35F8CC479449609E8A0923A6" ma:contentTypeVersion="32" ma:contentTypeDescription="Create a new document." ma:contentTypeScope="" ma:versionID="0635a23c60cc3de58ab4c1efc88efc6e">
   <xsd:schema xmlns:xsd="http://www.w3.org/2001/XMLSchema" xmlns:xs="http://www.w3.org/2001/XMLSchema" xmlns:p="http://schemas.microsoft.com/office/2006/metadata/properties" xmlns:ns1="http://schemas.microsoft.com/sharepoint/v3" xmlns:ns2="71af3243-3dd4-4a8d-8c0d-dd76da1f02a5" xmlns:ns3="16c05727-aa75-4e4a-9b5f-8a80a1165891" xmlns:ns4="230e9df3-be65-4c73-a93b-d1236ebd677e" targetNamespace="http://schemas.microsoft.com/office/2006/metadata/properties" ma:root="true" ma:fieldsID="b2ec4e1d644ed04c8d3fd0ef60d056a4" ns1:_="" ns2:_="" ns3:_="" ns4:_="">
     <xsd:import namespace="http://schemas.microsoft.com/sharepoint/v3"/>
@@ -15491,10 +15815,52 @@
 </ct:contentTypeSchema>
 </file>
 
+<file path=customXml/item2.xml><?xml version="1.0" encoding="utf-8"?>
+<p:properties xmlns:p="http://schemas.microsoft.com/office/2006/metadata/properties" xmlns:xsi="http://www.w3.org/2001/XMLSchema-instance" xmlns:pc="http://schemas.microsoft.com/office/infopath/2007/PartnerControls">
+  <documentManagement>
+    <_ip_UnifiedCompliancePolicyUIAction xmlns="http://schemas.microsoft.com/sharepoint/v3" xsi:nil="true"/>
+    <Image xmlns="71af3243-3dd4-4a8d-8c0d-dd76da1f02a5">
+      <Url xsi:nil="true"/>
+      <Description xsi:nil="true"/>
+    </Image>
+    <Status xmlns="71af3243-3dd4-4a8d-8c0d-dd76da1f02a5">Not started</Status>
+    <Background xmlns="71af3243-3dd4-4a8d-8c0d-dd76da1f02a5">false</Background>
+    <_ip_UnifiedCompliancePolicyProperties xmlns="http://schemas.microsoft.com/sharepoint/v3" xsi:nil="true"/>
+    <ImageTagsTaxHTField xmlns="71af3243-3dd4-4a8d-8c0d-dd76da1f02a5">
+      <Terms xmlns="http://schemas.microsoft.com/office/infopath/2007/PartnerControls"/>
+    </ImageTagsTaxHTField>
+    <TaxCatchAll xmlns="230e9df3-be65-4c73-a93b-d1236ebd677e" xsi:nil="true"/>
+    <MediaServiceKeyPoints xmlns="71af3243-3dd4-4a8d-8c0d-dd76da1f02a5" xsi:nil="true"/>
+  </documentManagement>
+</p:properties>
+</file>
+
+<file path=customXml/item3.xml><?xml version="1.0" encoding="utf-8"?>
+<?mso-contentType ?>
+<FormTemplates xmlns="http://schemas.microsoft.com/sharepoint/v3/contenttype/forms">
+  <Display>DocumentLibraryForm</Display>
+  <Edit>DocumentLibraryForm</Edit>
+  <New>DocumentLibraryForm</New>
+</FormTemplates>
+</file>
+
 <file path=customXml/itemProps1.xml><?xml version="1.0" encoding="utf-8"?>
-<ds:datastoreItem xmlns:ds="http://schemas.openxmlformats.org/officeDocument/2006/customXml" ds:itemID="{38E339AF-67FC-4BA3-8B2E-038B3ED310D5}">
+<ds:datastoreItem xmlns:ds="http://schemas.openxmlformats.org/officeDocument/2006/customXml" ds:itemID="{1CAF6374-A7FD-4717-AFE0-646B462CEB63}">
   <ds:schemaRefs>
-    <ds:schemaRef ds:uri="http://schemas.microsoft.com/sharepoint/v3/contenttype/forms"/>
+    <ds:schemaRef ds:uri="http://schemas.microsoft.com/office/2006/metadata/contentType"/>
+    <ds:schemaRef ds:uri="http://schemas.microsoft.com/office/2006/metadata/properties/metaAttributes"/>
+    <ds:schemaRef ds:uri="http://www.w3.org/2001/XMLSchema"/>
+    <ds:schemaRef ds:uri="http://schemas.microsoft.com/office/2006/metadata/properties"/>
+    <ds:schemaRef ds:uri="http://schemas.microsoft.com/sharepoint/v3"/>
+    <ds:schemaRef ds:uri="71af3243-3dd4-4a8d-8c0d-dd76da1f02a5"/>
+    <ds:schemaRef ds:uri="16c05727-aa75-4e4a-9b5f-8a80a1165891"/>
+    <ds:schemaRef ds:uri="230e9df3-be65-4c73-a93b-d1236ebd677e"/>
+    <ds:schemaRef ds:uri="http://schemas.microsoft.com/office/2006/documentManagement/types"/>
+    <ds:schemaRef ds:uri="http://schemas.microsoft.com/office/infopath/2007/PartnerControls"/>
+    <ds:schemaRef ds:uri="http://schemas.openxmlformats.org/package/2006/metadata/core-properties"/>
+    <ds:schemaRef ds:uri="http://purl.org/dc/elements/1.1/"/>
+    <ds:schemaRef ds:uri="http://purl.org/dc/terms/"/>
+    <ds:schemaRef ds:uri="http://schemas.microsoft.com/internal/obd"/>
   </ds:schemaRefs>
 </ds:datastoreItem>
 </file>
@@ -15519,22 +15885,9 @@
 </file>
 
 <file path=customXml/itemProps3.xml><?xml version="1.0" encoding="utf-8"?>
-<ds:datastoreItem xmlns:ds="http://schemas.openxmlformats.org/officeDocument/2006/customXml" ds:itemID="{1CAF6374-A7FD-4717-AFE0-646B462CEB63}">
+<ds:datastoreItem xmlns:ds="http://schemas.openxmlformats.org/officeDocument/2006/customXml" ds:itemID="{38E339AF-67FC-4BA3-8B2E-038B3ED310D5}">
   <ds:schemaRefs>
-    <ds:schemaRef ds:uri="http://schemas.microsoft.com/office/2006/metadata/contentType"/>
-    <ds:schemaRef ds:uri="http://schemas.microsoft.com/office/2006/metadata/properties/metaAttributes"/>
-    <ds:schemaRef ds:uri="http://www.w3.org/2001/XMLSchema"/>
-    <ds:schemaRef ds:uri="http://schemas.microsoft.com/office/2006/metadata/properties"/>
-    <ds:schemaRef ds:uri="http://schemas.microsoft.com/sharepoint/v3"/>
-    <ds:schemaRef ds:uri="71af3243-3dd4-4a8d-8c0d-dd76da1f02a5"/>
-    <ds:schemaRef ds:uri="16c05727-aa75-4e4a-9b5f-8a80a1165891"/>
-    <ds:schemaRef ds:uri="230e9df3-be65-4c73-a93b-d1236ebd677e"/>
-    <ds:schemaRef ds:uri="http://schemas.microsoft.com/office/2006/documentManagement/types"/>
-    <ds:schemaRef ds:uri="http://schemas.microsoft.com/office/infopath/2007/PartnerControls"/>
-    <ds:schemaRef ds:uri="http://schemas.openxmlformats.org/package/2006/metadata/core-properties"/>
-    <ds:schemaRef ds:uri="http://purl.org/dc/elements/1.1/"/>
-    <ds:schemaRef ds:uri="http://purl.org/dc/terms/"/>
-    <ds:schemaRef ds:uri="http://schemas.microsoft.com/internal/obd"/>
+    <ds:schemaRef ds:uri="http://schemas.microsoft.com/sharepoint/v3/contenttype/forms"/>
   </ds:schemaRefs>
 </ds:datastoreItem>
 </file>

</xml_diff>

<commit_message>
Add my part to the slide and enhanced the format and animation.
</commit_message>
<xml_diff>
--- a/Cybersecurity.pptx
+++ b/Cybersecurity.pptx
@@ -13929,6 +13929,18 @@
   <p:clrMapOvr>
     <a:masterClrMapping/>
   </p:clrMapOvr>
+  <mc:AlternateContent xmlns:mc="http://schemas.openxmlformats.org/markup-compatibility/2006">
+    <mc:Choice xmlns:p159="http://schemas.microsoft.com/office/powerpoint/2015/09/main" Requires="p159">
+      <p:transition xmlns:p14="http://schemas.microsoft.com/office/powerpoint/2010/main" spd="slow" p14:dur="2000">
+        <p159:morph option="byObject"/>
+      </p:transition>
+    </mc:Choice>
+    <mc:Fallback>
+      <p:transition spd="slow">
+        <p:fade/>
+      </p:transition>
+    </mc:Fallback>
+  </mc:AlternateContent>
 </p:sld>
 </file>
 
@@ -14008,7 +14020,7 @@
         <p:spPr>
           <a:xfrm>
             <a:off x="6324600" y="1385287"/>
-            <a:ext cx="5181600" cy="4573655"/>
+            <a:ext cx="5181600" cy="4692240"/>
           </a:xfrm>
         </p:spPr>
         <p:txBody>
@@ -14022,7 +14034,7 @@
               <a:buChar char="•"/>
             </a:pPr>
             <a:r>
-              <a:rPr lang="en-CA" dirty="0"/>
+              <a:rPr lang="en-CA" sz="1700" b="1" dirty="0"/>
               <a:t>Unintentional release of information</a:t>
             </a:r>
           </a:p>
@@ -14032,7 +14044,7 @@
               <a:buChar char="•"/>
             </a:pPr>
             <a:r>
-              <a:rPr lang="en-CA" dirty="0"/>
+              <a:rPr lang="en-CA" sz="1700" b="1" dirty="0"/>
               <a:t>Deliberate</a:t>
             </a:r>
           </a:p>
@@ -14112,7 +14124,7 @@
               <a:buChar char="•"/>
             </a:pPr>
             <a:r>
-              <a:rPr lang="en-CA" dirty="0"/>
+              <a:rPr lang="en-CA" sz="1700" b="1" dirty="0"/>
               <a:t>Accidental</a:t>
             </a:r>
           </a:p>
@@ -14142,7 +14154,7 @@
               <a:buChar char="•"/>
             </a:pPr>
             <a:r>
-              <a:rPr lang="en-CA" dirty="0"/>
+              <a:rPr lang="en-CA" sz="1700" b="1" dirty="0"/>
               <a:t>Proxy</a:t>
             </a:r>
           </a:p>
@@ -14175,6 +14187,18 @@
   <p:clrMapOvr>
     <a:masterClrMapping/>
   </p:clrMapOvr>
+  <mc:AlternateContent xmlns:mc="http://schemas.openxmlformats.org/markup-compatibility/2006">
+    <mc:Choice xmlns:p14="http://schemas.microsoft.com/office/powerpoint/2010/main" Requires="p14">
+      <p:transition spd="med" p14:dur="700">
+        <p:fade/>
+      </p:transition>
+    </mc:Choice>
+    <mc:Fallback>
+      <p:transition spd="med">
+        <p:fade/>
+      </p:transition>
+    </mc:Fallback>
+  </mc:AlternateContent>
 </p:sld>
 </file>
 
@@ -14241,13 +14265,13 @@
         </p:nvSpPr>
         <p:spPr>
           <a:xfrm>
-            <a:off x="704084" y="1600199"/>
-            <a:ext cx="5735507" cy="5119719"/>
+            <a:off x="704084" y="1413165"/>
+            <a:ext cx="5735507" cy="5306754"/>
           </a:xfrm>
         </p:spPr>
         <p:txBody>
           <a:bodyPr>
-            <a:normAutofit lnSpcReduction="10000"/>
+            <a:normAutofit fontScale="92500" lnSpcReduction="10000"/>
           </a:bodyPr>
           <a:lstStyle/>
           <a:p>
@@ -14256,7 +14280,7 @@
               <a:buChar char="•"/>
             </a:pPr>
             <a:r>
-              <a:rPr lang="en-CA" dirty="0"/>
+              <a:rPr lang="en-CA" sz="1700" b="1" dirty="0"/>
               <a:t>September 2026</a:t>
             </a:r>
           </a:p>
@@ -14282,11 +14306,14 @@
           </a:p>
           <a:p>
             <a:pPr marL="514350" indent="-285750">
+              <a:lnSpc>
+                <a:spcPct val="110000"/>
+              </a:lnSpc>
               <a:buFont typeface="Arial" panose="020B0604020202020204" pitchFamily="34" charset="0"/>
               <a:buChar char="•"/>
             </a:pPr>
             <a:r>
-              <a:rPr lang="en-CA" dirty="0"/>
+              <a:rPr lang="en-CA" sz="1700" b="1" dirty="0"/>
               <a:t>Yahoo (2013)</a:t>
             </a:r>
           </a:p>
@@ -14332,11 +14359,14 @@
           </a:p>
           <a:p>
             <a:pPr marL="514350" indent="-285750">
+              <a:lnSpc>
+                <a:spcPct val="120000"/>
+              </a:lnSpc>
               <a:buFont typeface="Arial" panose="020B0604020202020204" pitchFamily="34" charset="0"/>
               <a:buChar char="•"/>
             </a:pPr>
             <a:r>
-              <a:rPr lang="en-CA" dirty="0"/>
+              <a:rPr lang="en-CA" sz="1700" b="1" dirty="0"/>
               <a:t>First American Financial (2019)</a:t>
             </a:r>
           </a:p>
@@ -14352,11 +14382,14 @@
           </a:p>
           <a:p>
             <a:pPr marL="514350" indent="-285750">
+              <a:lnSpc>
+                <a:spcPct val="130000"/>
+              </a:lnSpc>
               <a:buFont typeface="Arial" panose="020B0604020202020204" pitchFamily="34" charset="0"/>
               <a:buChar char="•"/>
             </a:pPr>
             <a:r>
-              <a:rPr lang="en-CA" dirty="0"/>
+              <a:rPr lang="en-CA" sz="1700" b="1" dirty="0"/>
               <a:t>Marriott International (2018)</a:t>
             </a:r>
           </a:p>
@@ -14372,11 +14405,14 @@
           </a:p>
           <a:p>
             <a:pPr marL="514350" indent="-285750">
+              <a:lnSpc>
+                <a:spcPct val="140000"/>
+              </a:lnSpc>
               <a:buFont typeface="Arial" panose="020B0604020202020204" pitchFamily="34" charset="0"/>
               <a:buChar char="•"/>
             </a:pPr>
             <a:r>
-              <a:rPr lang="en-CA" dirty="0"/>
+              <a:rPr lang="en-CA" sz="1700" b="1" dirty="0"/>
               <a:t>National Public Data (2024)</a:t>
             </a:r>
           </a:p>
@@ -14402,6 +14438,9 @@
   <p:clrMapOvr>
     <a:masterClrMapping/>
   </p:clrMapOvr>
+  <p:transition spd="slow">
+    <p:push dir="u"/>
+  </p:transition>
 </p:sld>
 </file>
 
@@ -14438,65 +14477,153 @@
             <p:ph type="ctrTitle"/>
           </p:nvPr>
         </p:nvSpPr>
-        <p:spPr/>
+        <p:spPr>
+          <a:xfrm>
+            <a:off x="6058619" y="609601"/>
+            <a:ext cx="5447581" cy="2179781"/>
+          </a:xfrm>
+        </p:spPr>
         <p:txBody>
           <a:bodyPr/>
           <a:lstStyle/>
           <a:p>
             <a:r>
               <a:rPr lang="en-CA" dirty="0"/>
-              <a:t>3</a:t>
-            </a:r>
-          </a:p>
-        </p:txBody>
-      </p:sp>
-      <p:sp>
-        <p:nvSpPr>
-          <p:cNvPr id="3" name="Subtitle 2">
-            <a:extLst>
-              <a:ext uri="{FF2B5EF4-FFF2-40B4-BE49-F238E27FC236}">
-                <a16:creationId xmlns:a16="http://schemas.microsoft.com/office/drawing/2014/main" id="{F407C6A2-4C94-5E6A-3A26-0C061486EEAB}"/>
-              </a:ext>
-            </a:extLst>
-          </p:cNvPr>
-          <p:cNvSpPr>
-            <a:spLocks noGrp="1"/>
+              <a:t>The future of data breaches</a:t>
+            </a:r>
+            <a:br>
+              <a:rPr lang="en-CA" dirty="0"/>
+            </a:br>
+            <a:endParaRPr lang="en-CA" dirty="0"/>
+          </a:p>
+        </p:txBody>
+      </p:sp>
+      <p:sp>
+        <p:nvSpPr>
+          <p:cNvPr id="7" name="Rectangle 3">
+            <a:extLst>
+              <a:ext uri="{FF2B5EF4-FFF2-40B4-BE49-F238E27FC236}">
+                <a16:creationId xmlns:a16="http://schemas.microsoft.com/office/drawing/2014/main" id="{FC790C3E-D0D5-5A43-6DE2-54B99386DEA5}"/>
+              </a:ext>
+            </a:extLst>
+          </p:cNvPr>
+          <p:cNvSpPr>
+            <a:spLocks noGrp="1" noChangeArrowheads="1"/>
           </p:cNvSpPr>
           <p:nvPr>
             <p:ph type="subTitle" idx="1"/>
           </p:nvPr>
         </p:nvSpPr>
-        <p:spPr/>
-        <p:txBody>
-          <a:bodyPr/>
+        <p:spPr bwMode="auto">
+          <a:xfrm>
+            <a:off x="6058619" y="2452160"/>
+            <a:ext cx="4292012" cy="2526333"/>
+          </a:xfrm>
+          <a:prstGeom prst="rect">
+            <a:avLst/>
+          </a:prstGeom>
+          <a:noFill/>
+          <a:ln>
+            <a:noFill/>
+          </a:ln>
+          <a:effectLst/>
+          <a:extLst>
+            <a:ext uri="{909E8E84-426E-40DD-AFC4-6F175D3DCCD1}">
+              <a14:hiddenFill xmlns:a14="http://schemas.microsoft.com/office/drawing/2010/main">
+                <a:solidFill>
+                  <a:schemeClr val="accent1"/>
+                </a:solidFill>
+              </a14:hiddenFill>
+            </a:ext>
+            <a:ext uri="{91240B29-F687-4F45-9708-019B960494DF}">
+              <a14:hiddenLine xmlns:a14="http://schemas.microsoft.com/office/drawing/2010/main" w="9525">
+                <a:solidFill>
+                  <a:schemeClr val="tx1"/>
+                </a:solidFill>
+                <a:miter lim="800000"/>
+                <a:headEnd/>
+                <a:tailEnd/>
+              </a14:hiddenLine>
+            </a:ext>
+            <a:ext uri="{AF507438-7753-43E0-B8FC-AC1667EBCBE1}">
+              <a14:hiddenEffects xmlns:a14="http://schemas.microsoft.com/office/drawing/2010/main">
+                <a:effectLst>
+                  <a:outerShdw dist="35921" dir="2700000" algn="ctr" rotWithShape="0">
+                    <a:schemeClr val="bg2"/>
+                  </a:outerShdw>
+                </a:effectLst>
+              </a14:hiddenEffects>
+            </a:ext>
+          </a:extLst>
+        </p:spPr>
+        <p:txBody>
+          <a:bodyPr vert="horz" wrap="square" lIns="91440" tIns="45720" rIns="91440" bIns="45720" numCol="1" anchor="ctr" anchorCtr="0" compatLnSpc="1">
+            <a:prstTxWarp prst="textNoShape">
+              <a:avLst/>
+            </a:prstTxWarp>
+            <a:spAutoFit/>
+          </a:bodyPr>
           <a:lstStyle/>
           <a:p>
-            <a:endParaRPr lang="en-CA"/>
-          </a:p>
-        </p:txBody>
-      </p:sp>
-      <p:sp>
-        <p:nvSpPr>
-          <p:cNvPr id="4" name="Picture Placeholder 3">
-            <a:extLst>
-              <a:ext uri="{FF2B5EF4-FFF2-40B4-BE49-F238E27FC236}">
-                <a16:creationId xmlns:a16="http://schemas.microsoft.com/office/drawing/2014/main" id="{6F72DA32-A511-8B82-059A-B76D716BC153}"/>
-              </a:ext>
-            </a:extLst>
-          </p:cNvPr>
-          <p:cNvSpPr>
-            <a:spLocks noGrp="1" noChangeAspect="1"/>
-          </p:cNvSpPr>
-          <p:nvPr>
-            <p:ph type="pic" sz="quarter" idx="13"/>
-          </p:nvPr>
-        </p:nvSpPr>
-        <p:spPr/>
-        <p:txBody>
-          <a:bodyPr/>
-          <a:lstStyle/>
-          <a:p>
-            <a:endParaRPr lang="en-CA"/>
+            <a:pPr marL="514350" indent="-285750">
+              <a:buFont typeface="Arial" panose="020B0604020202020204" pitchFamily="34" charset="0"/>
+              <a:buChar char="•"/>
+            </a:pPr>
+            <a:r>
+              <a:rPr lang="en-CA" altLang="zh-CN" b="1" dirty="0"/>
+              <a:t>AI-Powered Cyberattacks</a:t>
+            </a:r>
+          </a:p>
+          <a:p>
+            <a:pPr marL="742950" lvl="1" indent="-285750">
+              <a:buFont typeface="Arial" panose="020B0604020202020204" pitchFamily="34" charset="0"/>
+              <a:buChar char="•"/>
+            </a:pPr>
+            <a:r>
+              <a:rPr lang="en-US" altLang="zh-CN" dirty="0"/>
+              <a:t>Smarter and more convincing cyberattacks</a:t>
+            </a:r>
+            <a:endParaRPr lang="en-CA" altLang="zh-CN" dirty="0"/>
+          </a:p>
+          <a:p>
+            <a:pPr marL="514350" indent="-285750">
+              <a:buFont typeface="Arial" panose="020B0604020202020204" pitchFamily="34" charset="0"/>
+              <a:buChar char="•"/>
+            </a:pPr>
+            <a:r>
+              <a:rPr lang="en-CA" altLang="zh-CN" b="1" dirty="0"/>
+              <a:t>Growing Data Security Risks</a:t>
+            </a:r>
+          </a:p>
+          <a:p>
+            <a:pPr marL="742950" lvl="1" indent="-285750">
+              <a:buFont typeface="Arial" panose="020B0604020202020204" pitchFamily="34" charset="0"/>
+              <a:buChar char="•"/>
+            </a:pPr>
+            <a:r>
+              <a:rPr lang="en-US" altLang="zh-CN" dirty="0"/>
+              <a:t>More personal information at risk</a:t>
+            </a:r>
+          </a:p>
+          <a:p>
+            <a:pPr marL="514350" indent="-285750">
+              <a:buFont typeface="Arial" panose="020B0604020202020204" pitchFamily="34" charset="0"/>
+              <a:buChar char="•"/>
+            </a:pPr>
+            <a:r>
+              <a:rPr lang="en-CA" altLang="zh-CN" b="1" dirty="0"/>
+              <a:t>Advanced Security Technology</a:t>
+            </a:r>
+          </a:p>
+          <a:p>
+            <a:pPr marL="742950" lvl="1" indent="-285750">
+              <a:buFont typeface="Arial" panose="020B0604020202020204" pitchFamily="34" charset="0"/>
+              <a:buChar char="•"/>
+            </a:pPr>
+            <a:r>
+              <a:rPr lang="en-CA" altLang="zh-CN" dirty="0"/>
+              <a:t>Faster detection and prevention</a:t>
+            </a:r>
           </a:p>
         </p:txBody>
       </p:sp>
@@ -14510,6 +14637,18 @@
   <p:clrMapOvr>
     <a:masterClrMapping/>
   </p:clrMapOvr>
+  <mc:AlternateContent xmlns:mc="http://schemas.openxmlformats.org/markup-compatibility/2006">
+    <mc:Choice xmlns:p14="http://schemas.microsoft.com/office/powerpoint/2010/main" Requires="p14">
+      <p:transition spd="slow" p14:dur="3400">
+        <p14:reveal/>
+      </p:transition>
+    </mc:Choice>
+    <mc:Fallback>
+      <p:transition spd="slow">
+        <p:fade/>
+      </p:transition>
+    </mc:Fallback>
+  </mc:AlternateContent>
 </p:sld>
 </file>
 
@@ -14551,9 +14690,10 @@
           <a:bodyPr/>
           <a:lstStyle/>
           <a:p>
-            <a:r>
-              <a:rPr lang="en-CA" dirty="0"/>
-              <a:t>4</a:t>
+            <a:pPr algn="l"/>
+            <a:r>
+              <a:rPr lang="en-US" altLang="zh-CN" b="1" dirty="0"/>
+              <a:t>How to Protect Yourself from Data Breaches</a:t>
             </a:r>
           </a:p>
         </p:txBody>
@@ -14579,7 +14719,59 @@
           <a:bodyPr/>
           <a:lstStyle/>
           <a:p>
-            <a:endParaRPr lang="en-CA"/>
+            <a:r>
+              <a:rPr lang="en-US" altLang="zh-CN" sz="1600" b="1" dirty="0"/>
+              <a:t>Strong Passwords </a:t>
+            </a:r>
+          </a:p>
+          <a:p>
+            <a:pPr lvl="1"/>
+            <a:r>
+              <a:rPr lang="en-US" altLang="zh-CN" dirty="0"/>
+              <a:t>Unique passwords for every account</a:t>
+            </a:r>
+          </a:p>
+          <a:p>
+            <a:r>
+              <a:rPr lang="en-US" altLang="zh-CN" sz="1600" b="1" dirty="0"/>
+              <a:t>Two-Factor Authentication </a:t>
+            </a:r>
+          </a:p>
+          <a:p>
+            <a:pPr lvl="1"/>
+            <a:r>
+              <a:rPr lang="en-US" altLang="zh-CN" dirty="0"/>
+              <a:t>An extra layer of account security</a:t>
+            </a:r>
+          </a:p>
+          <a:p>
+            <a:r>
+              <a:rPr lang="en-US" altLang="zh-CN" sz="1600" b="1" dirty="0"/>
+              <a:t>Avoid Suspicious Links </a:t>
+            </a:r>
+          </a:p>
+          <a:p>
+            <a:pPr lvl="1"/>
+            <a:r>
+              <a:rPr lang="en-US" altLang="zh-CN" dirty="0"/>
+              <a:t>Protect yourself from phishing attacks</a:t>
+            </a:r>
+          </a:p>
+          <a:p>
+            <a:r>
+              <a:rPr lang="en-US" altLang="zh-CN" sz="1600" b="1" dirty="0"/>
+              <a:t>Regular Software Updates </a:t>
+            </a:r>
+          </a:p>
+          <a:p>
+            <a:pPr lvl="1"/>
+            <a:r>
+              <a:rPr lang="en-US" altLang="zh-CN" dirty="0"/>
+              <a:t>Fix vulnerabilities and improve security</a:t>
+            </a:r>
+          </a:p>
+          <a:p>
+            <a:endParaRPr lang="en-CA" dirty="0"/>
           </a:p>
         </p:txBody>
       </p:sp>
@@ -14593,6 +14785,18 @@
   <p:clrMapOvr>
     <a:masterClrMapping/>
   </p:clrMapOvr>
+  <mc:AlternateContent xmlns:mc="http://schemas.openxmlformats.org/markup-compatibility/2006">
+    <mc:Choice xmlns:p14="http://schemas.microsoft.com/office/powerpoint/2010/main" Requires="p14">
+      <p:transition p14:dur="100">
+        <p:cut/>
+      </p:transition>
+    </mc:Choice>
+    <mc:Fallback>
+      <p:transition>
+        <p:cut/>
+      </p:transition>
+    </mc:Fallback>
+  </mc:AlternateContent>
 </p:sld>
 </file>
 
@@ -14651,6 +14855,9 @@
   <p:clrMapOvr>
     <a:masterClrMapping/>
   </p:clrMapOvr>
+  <p:transition spd="med">
+    <p:pull/>
+  </p:transition>
 </p:sld>
 </file>
 
@@ -15486,6 +15693,26 @@
 </file>
 
 <file path=customXml/item1.xml><?xml version="1.0" encoding="utf-8"?>
+<p:properties xmlns:p="http://schemas.microsoft.com/office/2006/metadata/properties" xmlns:xsi="http://www.w3.org/2001/XMLSchema-instance" xmlns:pc="http://schemas.microsoft.com/office/infopath/2007/PartnerControls">
+  <documentManagement>
+    <_ip_UnifiedCompliancePolicyUIAction xmlns="http://schemas.microsoft.com/sharepoint/v3" xsi:nil="true"/>
+    <Image xmlns="71af3243-3dd4-4a8d-8c0d-dd76da1f02a5">
+      <Url xsi:nil="true"/>
+      <Description xsi:nil="true"/>
+    </Image>
+    <Status xmlns="71af3243-3dd4-4a8d-8c0d-dd76da1f02a5">Not started</Status>
+    <Background xmlns="71af3243-3dd4-4a8d-8c0d-dd76da1f02a5">false</Background>
+    <_ip_UnifiedCompliancePolicyProperties xmlns="http://schemas.microsoft.com/sharepoint/v3" xsi:nil="true"/>
+    <ImageTagsTaxHTField xmlns="71af3243-3dd4-4a8d-8c0d-dd76da1f02a5">
+      <Terms xmlns="http://schemas.microsoft.com/office/infopath/2007/PartnerControls"/>
+    </ImageTagsTaxHTField>
+    <TaxCatchAll xmlns="230e9df3-be65-4c73-a93b-d1236ebd677e" xsi:nil="true"/>
+    <MediaServiceKeyPoints xmlns="71af3243-3dd4-4a8d-8c0d-dd76da1f02a5" xsi:nil="true"/>
+  </documentManagement>
+</p:properties>
+</file>
+
+<file path=customXml/item2.xml><?xml version="1.0" encoding="utf-8"?>
 <ct:contentTypeSchema xmlns:ct="http://schemas.microsoft.com/office/2006/metadata/contentType" xmlns:ma="http://schemas.microsoft.com/office/2006/metadata/properties/metaAttributes" ct:_="" ma:_="" ma:contentTypeName="Document" ma:contentTypeID="0x01010079F111ED35F8CC479449609E8A0923A6" ma:contentTypeVersion="32" ma:contentTypeDescription="Create a new document." ma:contentTypeScope="" ma:versionID="0635a23c60cc3de58ab4c1efc88efc6e">
   <xsd:schema xmlns:xsd="http://www.w3.org/2001/XMLSchema" xmlns:xs="http://www.w3.org/2001/XMLSchema" xmlns:p="http://schemas.microsoft.com/office/2006/metadata/properties" xmlns:ns1="http://schemas.microsoft.com/sharepoint/v3" xmlns:ns2="71af3243-3dd4-4a8d-8c0d-dd76da1f02a5" xmlns:ns3="16c05727-aa75-4e4a-9b5f-8a80a1165891" xmlns:ns4="230e9df3-be65-4c73-a93b-d1236ebd677e" targetNamespace="http://schemas.microsoft.com/office/2006/metadata/properties" ma:root="true" ma:fieldsID="b2ec4e1d644ed04c8d3fd0ef60d056a4" ns1:_="" ns2:_="" ns3:_="" ns4:_="">
     <xsd:import namespace="http://schemas.microsoft.com/sharepoint/v3"/>
@@ -15815,26 +16042,6 @@
 </ct:contentTypeSchema>
 </file>
 
-<file path=customXml/item2.xml><?xml version="1.0" encoding="utf-8"?>
-<p:properties xmlns:p="http://schemas.microsoft.com/office/2006/metadata/properties" xmlns:xsi="http://www.w3.org/2001/XMLSchema-instance" xmlns:pc="http://schemas.microsoft.com/office/infopath/2007/PartnerControls">
-  <documentManagement>
-    <_ip_UnifiedCompliancePolicyUIAction xmlns="http://schemas.microsoft.com/sharepoint/v3" xsi:nil="true"/>
-    <Image xmlns="71af3243-3dd4-4a8d-8c0d-dd76da1f02a5">
-      <Url xsi:nil="true"/>
-      <Description xsi:nil="true"/>
-    </Image>
-    <Status xmlns="71af3243-3dd4-4a8d-8c0d-dd76da1f02a5">Not started</Status>
-    <Background xmlns="71af3243-3dd4-4a8d-8c0d-dd76da1f02a5">false</Background>
-    <_ip_UnifiedCompliancePolicyProperties xmlns="http://schemas.microsoft.com/sharepoint/v3" xsi:nil="true"/>
-    <ImageTagsTaxHTField xmlns="71af3243-3dd4-4a8d-8c0d-dd76da1f02a5">
-      <Terms xmlns="http://schemas.microsoft.com/office/infopath/2007/PartnerControls"/>
-    </ImageTagsTaxHTField>
-    <TaxCatchAll xmlns="230e9df3-be65-4c73-a93b-d1236ebd677e" xsi:nil="true"/>
-    <MediaServiceKeyPoints xmlns="71af3243-3dd4-4a8d-8c0d-dd76da1f02a5" xsi:nil="true"/>
-  </documentManagement>
-</p:properties>
-</file>
-
 <file path=customXml/item3.xml><?xml version="1.0" encoding="utf-8"?>
 <?mso-contentType ?>
 <FormTemplates xmlns="http://schemas.microsoft.com/sharepoint/v3/contenttype/forms">
@@ -15845,6 +16052,25 @@
 </file>
 
 <file path=customXml/itemProps1.xml><?xml version="1.0" encoding="utf-8"?>
+<ds:datastoreItem xmlns:ds="http://schemas.openxmlformats.org/officeDocument/2006/customXml" ds:itemID="{4B99ED26-B189-4BA1-99D0-1112D8C2F106}">
+  <ds:schemaRefs>
+    <ds:schemaRef ds:uri="http://purl.org/dc/terms/"/>
+    <ds:schemaRef ds:uri="http://schemas.microsoft.com/office/2006/metadata/properties"/>
+    <ds:schemaRef ds:uri="http://purl.org/dc/dcmitype/"/>
+    <ds:schemaRef ds:uri="http://schemas.microsoft.com/office/2006/documentManagement/types"/>
+    <ds:schemaRef ds:uri="230e9df3-be65-4c73-a93b-d1236ebd677e"/>
+    <ds:schemaRef ds:uri="http://purl.org/dc/elements/1.1/"/>
+    <ds:schemaRef ds:uri="http://schemas.microsoft.com/office/infopath/2007/PartnerControls"/>
+    <ds:schemaRef ds:uri="http://www.w3.org/XML/1998/namespace"/>
+    <ds:schemaRef ds:uri="http://schemas.openxmlformats.org/package/2006/metadata/core-properties"/>
+    <ds:schemaRef ds:uri="16c05727-aa75-4e4a-9b5f-8a80a1165891"/>
+    <ds:schemaRef ds:uri="71af3243-3dd4-4a8d-8c0d-dd76da1f02a5"/>
+    <ds:schemaRef ds:uri="http://schemas.microsoft.com/sharepoint/v3"/>
+  </ds:schemaRefs>
+</ds:datastoreItem>
+</file>
+
+<file path=customXml/itemProps2.xml><?xml version="1.0" encoding="utf-8"?>
 <ds:datastoreItem xmlns:ds="http://schemas.openxmlformats.org/officeDocument/2006/customXml" ds:itemID="{1CAF6374-A7FD-4717-AFE0-646B462CEB63}">
   <ds:schemaRefs>
     <ds:schemaRef ds:uri="http://schemas.microsoft.com/office/2006/metadata/contentType"/>
@@ -15865,25 +16091,6 @@
 </ds:datastoreItem>
 </file>
 
-<file path=customXml/itemProps2.xml><?xml version="1.0" encoding="utf-8"?>
-<ds:datastoreItem xmlns:ds="http://schemas.openxmlformats.org/officeDocument/2006/customXml" ds:itemID="{4B99ED26-B189-4BA1-99D0-1112D8C2F106}">
-  <ds:schemaRefs>
-    <ds:schemaRef ds:uri="http://purl.org/dc/terms/"/>
-    <ds:schemaRef ds:uri="http://schemas.microsoft.com/office/2006/metadata/properties"/>
-    <ds:schemaRef ds:uri="http://purl.org/dc/dcmitype/"/>
-    <ds:schemaRef ds:uri="http://schemas.microsoft.com/office/2006/documentManagement/types"/>
-    <ds:schemaRef ds:uri="230e9df3-be65-4c73-a93b-d1236ebd677e"/>
-    <ds:schemaRef ds:uri="http://purl.org/dc/elements/1.1/"/>
-    <ds:schemaRef ds:uri="http://schemas.microsoft.com/office/infopath/2007/PartnerControls"/>
-    <ds:schemaRef ds:uri="http://www.w3.org/XML/1998/namespace"/>
-    <ds:schemaRef ds:uri="http://schemas.openxmlformats.org/package/2006/metadata/core-properties"/>
-    <ds:schemaRef ds:uri="16c05727-aa75-4e4a-9b5f-8a80a1165891"/>
-    <ds:schemaRef ds:uri="71af3243-3dd4-4a8d-8c0d-dd76da1f02a5"/>
-    <ds:schemaRef ds:uri="http://schemas.microsoft.com/sharepoint/v3"/>
-  </ds:schemaRefs>
-</ds:datastoreItem>
-</file>
-
 <file path=customXml/itemProps3.xml><?xml version="1.0" encoding="utf-8"?>
 <ds:datastoreItem xmlns:ds="http://schemas.openxmlformats.org/officeDocument/2006/customXml" ds:itemID="{38E339AF-67FC-4BA3-8B2E-038B3ED310D5}">
   <ds:schemaRefs>

</xml_diff>